<commit_message>
poster: swap the copula-gain bars for the complexity-value frontier (line)
- Replace the third bar chart in the "does sophistication pay?" column with the
  2D complexity-value frontier line (one jump at transfer, then flat). The copula
  message ("even the maximal copula adds nothing") still appears in the column's
  text box, so nothing is lost, and the poster gains visual variety plus a
  value-first line instead of a third bar chart.
- plot_complexity_frontier.py now renders both a thesis version (figures/) and a
  wider, larger-font poster version (poster/figs/).
- Rebuilt poster_capstone_v24.{pptx,pdf}.

No reported numbers changed.
</commit_message>
<xml_diff>
--- a/poster/poster_capstone_v24.pptx
+++ b/poster/poster_capstone_v24.pptx
@@ -5598,7 +5598,7 @@
         <p:spPr>
           <a:xfrm>
             <a:off x="15322296" y="24864876"/>
-            <a:ext cx="7083552" cy="2830935"/>
+            <a:ext cx="7083552" cy="2935957"/>
           </a:xfrm>
           <a:prstGeom prst="rect">
             <a:avLst/>
@@ -5616,7 +5616,7 @@
       </p:sp>
       <p:pic>
         <p:nvPicPr>
-          <p:cNvPr id="119" name="Image 7" descr="figs/copula_result.png">    </p:cNvPr>
+          <p:cNvPr id="119" name="Image 7" descr="figs/complexity_frontier.png">    </p:cNvPr>
           <p:cNvPicPr>
             <a:picLocks noChangeAspect="1"/>
           </p:cNvPicPr>
@@ -5630,7 +5630,7 @@
         <p:spPr>
           <a:xfrm>
             <a:off x="15486888" y="24983748"/>
-            <a:ext cx="6754368" cy="2593191"/>
+            <a:ext cx="6754368" cy="2698213"/>
           </a:xfrm>
           <a:prstGeom prst="rect">
             <a:avLst/>
@@ -5645,7 +5645,7 @@
         </p:nvSpPr>
         <p:spPr>
           <a:xfrm>
-            <a:off x="15441168" y="27714099"/>
+            <a:off x="15441168" y="27819121"/>
             <a:ext cx="6845808" cy="548640"/>
           </a:xfrm>
           <a:prstGeom prst="rect">
@@ -5673,7 +5673,7 @@
                 <a:ea typeface="Palatino Linotype" pitchFamily="34" charset="-122"/>
                 <a:cs typeface="Palatino Linotype" pitchFamily="34" charset="-120"/>
               </a:rPr>
-              <a:t>Gaussian, Clayton, even the comonotone (maximal) copula: </a:t>
+              <a:t>Cumulative savings vs. carbon-blind </a:t>
             </a:r>
             <a:pPr algn="l" indent="0" marL="0">
               <a:lnSpc>
@@ -5690,7 +5690,24 @@
                 <a:ea typeface="Palatino Linotype" pitchFamily="34" charset="-122"/>
                 <a:cs typeface="Palatino Linotype" pitchFamily="34" charset="-120"/>
               </a:rPr>
-              <a:t>every gain sits at the noise floor.</a:t>
+              <a:t>jump once (transfer), then stay flat</a:t>
+            </a:r>
+            <a:pPr algn="l" indent="0" marL="0">
+              <a:lnSpc>
+                <a:spcPct val="102000"/>
+              </a:lnSpc>
+              <a:buNone/>
+            </a:pPr>
+            <a:r>
+              <a:rPr lang="en-US" sz="1650" i="1" dirty="0">
+                <a:solidFill>
+                  <a:srgbClr val="586173"/>
+                </a:solidFill>
+                <a:latin typeface="Palatino Linotype" pitchFamily="34" charset="0"/>
+                <a:ea typeface="Palatino Linotype" pitchFamily="34" charset="-122"/>
+                <a:cs typeface="Palatino Linotype" pitchFamily="34" charset="-120"/>
+              </a:rPr>
+              <a:t>: joint covariance, the robust DRO, and copulas (Gaussian, Clayton, comonotone) each add nothing.</a:t>
             </a:r>
             <a:endParaRPr lang="en-US" sz="1650" dirty="0"/>
           </a:p>
@@ -5704,8 +5721,8 @@
         </p:nvSpPr>
         <p:spPr>
           <a:xfrm>
-            <a:off x="15441168" y="28372467"/>
-            <a:ext cx="6845808" cy="1436973"/>
+            <a:off x="15441168" y="28477489"/>
+            <a:ext cx="6845808" cy="1331951"/>
           </a:xfrm>
           <a:prstGeom prst="rect">
             <a:avLst/>
@@ -5724,8 +5741,8 @@
         </p:nvSpPr>
         <p:spPr>
           <a:xfrm>
-            <a:off x="15441168" y="28372467"/>
-            <a:ext cx="146304" cy="1436973"/>
+            <a:off x="15441168" y="28477489"/>
+            <a:ext cx="146304" cy="1331951"/>
           </a:xfrm>
           <a:prstGeom prst="rect">
             <a:avLst/>
@@ -5744,8 +5761,8 @@
         </p:nvSpPr>
         <p:spPr>
           <a:xfrm>
-            <a:off x="15752064" y="28372467"/>
-            <a:ext cx="6278880" cy="1436973"/>
+            <a:off x="15752064" y="28477489"/>
+            <a:ext cx="6278880" cy="1331951"/>
           </a:xfrm>
           <a:prstGeom prst="rect">
             <a:avLst/>

</xml_diff>

<commit_message>
Soften residual universal "never reach" claims; remove stale explainer
- Poster v24, README, and the extended full thesis: "a severity real grids never
  reach" -> "have not reached (about 1.4x in the data)" / "crossover does not
  activate", matching the scoped wording already in the graded report.
- Remove docs/explainer.html: a superseded null-first explainer that contradicted
  the value-first framing (the current companion is capstone_explained.html).
</commit_message>
<xml_diff>
--- a/poster/poster_capstone_v24.pptx
+++ b/poster/poster_capstone_v24.pptx
@@ -1952,7 +1952,7 @@
                 <a:ea typeface="Palatino Linotype" pitchFamily="34" charset="-122"/>
                 <a:cs typeface="Palatino Linotype" pitchFamily="34" charset="-120"/>
               </a:rPr>
-              <a:t>real grids never reach</a:t>
+              <a:t>real grids have not reached</a:t>
             </a:r>
             <a:pPr algn="ctr" indent="0" marL="0">
               <a:lnSpc>
@@ -7154,7 +7154,7 @@
                 <a:ea typeface="Palatino Linotype" pitchFamily="34" charset="-122"/>
                 <a:cs typeface="Palatino Linotype" pitchFamily="34" charset="-120"/>
               </a:rPr>
-              <a:t> cuts 4 to 10 percent of carbon, deterministically. The sophisticated layers (joint covariance, copulas, distributional robustness) add nothing until grid emergencies hit 3x severity, which real grids never reach. Deploy the simple migration scheduler; price robustness only if your grid faces genuine extremes.</a:t>
+              <a:t> cuts 4 to 10 percent of carbon, deterministically. The sophisticated layers (joint covariance, copulas, distributional robustness) add nothing until grid emergencies hit 3x severity, which real grids have not reached. Deploy the simple migration scheduler; price robustness only if your grid faces genuine extremes.</a:t>
             </a:r>
             <a:endParaRPr lang="en-US" sz="1900" dirty="0"/>
           </a:p>
@@ -7358,7 +7358,7 @@
                 <a:ea typeface="Palatino Linotype" pitchFamily="34" charset="-122"/>
                 <a:cs typeface="Palatino Linotype" pitchFamily="34" charset="-120"/>
               </a:rPr>
-              <a:t>Deploy the deterministic migration scheduler; skip joint-covariance and copula modeling; price robustness only past a severity real grids never reach.</a:t>
+              <a:t>Deploy the deterministic migration scheduler; skip joint-covariance and copula modeling; price robustness only past a severity real grids have not reached.</a:t>
             </a:r>
             <a:endParaRPr lang="en-US" sz="2500" dirty="0"/>
           </a:p>

</xml_diff>

<commit_message>
Poster: replace the abstract bound-vs-gap bars with a positive-control figure
The certificate_canyon chart (a-priori theorem bound vs realized gap, log bars) was
abstract and didn't land. Replace it with the mean-leveling positive control, which
fits the Mechanism column's narrative: each grid's spatial gap in the real world
(near zero, masked) vs a mean-flattened world where the cross-region signal appears
(Diversified +1.46%, Eastern +0.42%), with the 0.4% materiality line. Shows the test
fires when value exists, so the real-world null is a true negative. New reproducible
scripts/plot_positive_control.py (numbers trace to the *_ablate-flat snapshots);
poster rebuilt. The carbon-landscape area chart is kept.
</commit_message>
<xml_diff>
--- a/poster/poster_capstone_v24.pptx
+++ b/poster/poster_capstone_v24.pptx
@@ -6130,7 +6130,7 @@
       </p:sp>
       <p:pic>
         <p:nvPicPr>
-          <p:cNvPr id="130" name="Image 9" descr="figs/certificate_canyon.png">    </p:cNvPr>
+          <p:cNvPr id="130" name="Image 9" descr="figs/positive_control.png">    </p:cNvPr>
           <p:cNvPicPr>
             <a:picLocks noChangeAspect="1"/>
           </p:cNvPicPr>
@@ -6187,7 +6187,7 @@
                 <a:ea typeface="Palatino Linotype" pitchFamily="34" charset="-122"/>
                 <a:cs typeface="Palatino Linotype" pitchFamily="34" charset="-120"/>
               </a:rPr>
-              <a:t>The mean-dominance theorem caps the gap a-priori at </a:t>
+              <a:t>The </a:t>
             </a:r>
             <a:pPr algn="l" indent="0" marL="0">
               <a:lnSpc>
@@ -6204,7 +6204,7 @@
                 <a:ea typeface="Palatino Linotype" pitchFamily="34" charset="-122"/>
                 <a:cs typeface="Palatino Linotype" pitchFamily="34" charset="-120"/>
               </a:rPr>
-              <a:t>7 to 13% of CVaR</a:t>
+              <a:t>positive control</a:t>
             </a:r>
             <a:pPr algn="l" indent="0" marL="0">
               <a:lnSpc>
@@ -6221,7 +6221,41 @@
                 <a:ea typeface="Palatino Linotype" pitchFamily="34" charset="-122"/>
                 <a:cs typeface="Palatino Linotype" pitchFamily="34" charset="-120"/>
               </a:rPr>
-              <a:t>; the realized gap never exceeds 0.23%, about 100x below its own bound.</a:t>
+              <a:t>: flatten each region's mean and the cross-region signal appears (Diversified </a:t>
+            </a:r>
+            <a:pPr algn="l" indent="0" marL="0">
+              <a:lnSpc>
+                <a:spcPct val="102000"/>
+              </a:lnSpc>
+              <a:buNone/>
+            </a:pPr>
+            <a:r>
+              <a:rPr lang="en-US" sz="1650" b="1" i="1" dirty="0">
+                <a:solidFill>
+                  <a:srgbClr val="8A5C16"/>
+                </a:solidFill>
+                <a:latin typeface="Palatino Linotype" pitchFamily="34" charset="0"/>
+                <a:ea typeface="Palatino Linotype" pitchFamily="34" charset="-122"/>
+                <a:cs typeface="Palatino Linotype" pitchFamily="34" charset="-120"/>
+              </a:rPr>
+              <a:t>+1.46%</a:t>
+            </a:r>
+            <a:pPr algn="l" indent="0" marL="0">
+              <a:lnSpc>
+                <a:spcPct val="102000"/>
+              </a:lnSpc>
+              <a:buNone/>
+            </a:pPr>
+            <a:r>
+              <a:rPr lang="en-US" sz="1650" i="1" dirty="0">
+                <a:solidFill>
+                  <a:srgbClr val="586173"/>
+                </a:solidFill>
+                <a:latin typeface="Palatino Linotype" pitchFamily="34" charset="0"/>
+                <a:ea typeface="Palatino Linotype" pitchFamily="34" charset="-122"/>
+                <a:cs typeface="Palatino Linotype" pitchFamily="34" charset="-120"/>
+              </a:rPr>
+              <a:t>); in the real world it stays below the 0.4% line, so the null is a true negative.</a:t>
             </a:r>
             <a:endParaRPr lang="en-US" sz="1650" dirty="0"/>
           </a:p>

</xml_diff>